<commit_message>
Update sunum.pptx template (manual edits)
Co-Authored-By: Claude Sonnet 4.6 <noreply@anthropic.com>
</commit_message>
<xml_diff>
--- a/sunum.pptx
+++ b/sunum.pptx
@@ -264,7 +264,7 @@
             <a:fld id="{758D20BE-75D8-4BE3-89C8-6254F41C1DCC}" type="datetimeFigureOut">
               <a:rPr lang="en-US" smtClean="0"/>
               <a:pPr/>
-              <a:t>3/21/2026</a:t>
+              <a:t>3/23/2026</a:t>
             </a:fld>
             <a:endParaRPr lang="en-US"/>
           </a:p>
@@ -883,7 +883,7 @@
               <a:pPr>
                 <a:defRPr/>
               </a:pPr>
-              <a:t>21.03.2026</a:t>
+              <a:t>23.03.2026</a:t>
             </a:fld>
             <a:endParaRPr lang="tr-TR"/>
           </a:p>
@@ -1075,7 +1075,7 @@
               <a:pPr>
                 <a:defRPr/>
               </a:pPr>
-              <a:t>21.03.2026</a:t>
+              <a:t>23.03.2026</a:t>
             </a:fld>
             <a:endParaRPr lang="tr-TR"/>
           </a:p>
@@ -1277,7 +1277,7 @@
               <a:pPr>
                 <a:defRPr/>
               </a:pPr>
-              <a:t>21.03.2026</a:t>
+              <a:t>23.03.2026</a:t>
             </a:fld>
             <a:endParaRPr lang="tr-TR"/>
           </a:p>
@@ -2555,7 +2555,7 @@
               <a:pPr>
                 <a:defRPr/>
               </a:pPr>
-              <a:t>21.03.2026</a:t>
+              <a:t>23.03.2026</a:t>
             </a:fld>
             <a:endParaRPr lang="tr-TR"/>
           </a:p>
@@ -2819,7 +2819,7 @@
               <a:pPr>
                 <a:defRPr/>
               </a:pPr>
-              <a:t>21.03.2026</a:t>
+              <a:t>23.03.2026</a:t>
             </a:fld>
             <a:endParaRPr lang="tr-TR"/>
           </a:p>
@@ -3110,7 +3110,7 @@
               <a:pPr>
                 <a:defRPr/>
               </a:pPr>
-              <a:t>21.03.2026</a:t>
+              <a:t>23.03.2026</a:t>
             </a:fld>
             <a:endParaRPr lang="tr-TR"/>
           </a:p>
@@ -3515,7 +3515,7 @@
               <a:pPr>
                 <a:defRPr/>
               </a:pPr>
-              <a:t>21.03.2026</a:t>
+              <a:t>23.03.2026</a:t>
             </a:fld>
             <a:endParaRPr lang="tr-TR"/>
           </a:p>
@@ -3692,7 +3692,7 @@
               <a:pPr>
                 <a:defRPr/>
               </a:pPr>
-              <a:t>21.03.2026</a:t>
+              <a:t>23.03.2026</a:t>
             </a:fld>
             <a:endParaRPr lang="tr-TR"/>
           </a:p>
@@ -3809,7 +3809,7 @@
               <a:pPr>
                 <a:defRPr/>
               </a:pPr>
-              <a:t>21.03.2026</a:t>
+              <a:t>23.03.2026</a:t>
             </a:fld>
             <a:endParaRPr lang="tr-TR"/>
           </a:p>
@@ -4097,7 +4097,7 @@
               <a:pPr>
                 <a:defRPr/>
               </a:pPr>
-              <a:t>21.03.2026</a:t>
+              <a:t>23.03.2026</a:t>
             </a:fld>
             <a:endParaRPr lang="tr-TR"/>
           </a:p>
@@ -4741,7 +4741,7 @@
               <a:pPr>
                 <a:defRPr/>
               </a:pPr>
-              <a:t>21.03.2026</a:t>
+              <a:t>23.03.2026</a:t>
             </a:fld>
             <a:endParaRPr lang="tr-TR"/>
           </a:p>
@@ -5271,7 +5271,7 @@
               <a:pPr>
                 <a:defRPr/>
               </a:pPr>
-              <a:t>21.03.2026</a:t>
+              <a:t>23.03.2026</a:t>
             </a:fld>
             <a:endParaRPr lang="tr-TR"/>
           </a:p>
@@ -6360,42 +6360,26 @@
         </p:nvSpPr>
         <p:spPr>
           <a:xfrm>
-            <a:off x="6012160" y="5898467"/>
-            <a:ext cx="2028119" cy="461665"/>
+            <a:off x="5580112" y="5667634"/>
+            <a:ext cx="3024336" cy="461665"/>
           </a:xfrm>
           <a:prstGeom prst="rect">
             <a:avLst/>
           </a:prstGeom>
         </p:spPr>
         <p:txBody>
-          <a:bodyPr wrap="none">
+          <a:bodyPr wrap="square">
             <a:spAutoFit/>
           </a:bodyPr>
           <a:lstStyle/>
           <a:p>
-            <a:r>
-              <a:rPr lang="tr-TR" sz="2400" b="1" dirty="0" err="1">
-                <a:latin typeface="Brush Script MT" panose="03060802040406070304" pitchFamily="66" charset="0"/>
-                <a:ea typeface="+mj-ea"/>
-                <a:cs typeface="Calibri Light" panose="020F0302020204030204" pitchFamily="34" charset="0"/>
-              </a:rPr>
-              <a:t>Dt</a:t>
-            </a:r>
             <a:r>
               <a:rPr lang="tr-TR" sz="2400" b="1" dirty="0">
                 <a:latin typeface="Brush Script MT" panose="03060802040406070304" pitchFamily="66" charset="0"/>
                 <a:ea typeface="+mj-ea"/>
                 <a:cs typeface="Calibri Light" panose="020F0302020204030204" pitchFamily="34" charset="0"/>
               </a:rPr>
-              <a:t>. Mehmet </a:t>
-            </a:r>
-            <a:r>
-              <a:rPr lang="tr-TR" sz="2400" b="1" dirty="0" err="1">
-                <a:latin typeface="Brush Script MT" panose="03060802040406070304" pitchFamily="66" charset="0"/>
-                <a:ea typeface="+mj-ea"/>
-                <a:cs typeface="Calibri Light" panose="020F0302020204030204" pitchFamily="34" charset="0"/>
-              </a:rPr>
-              <a:t>Daş</a:t>
+              <a:t>Placeholder 300</a:t>
             </a:r>
             <a:endParaRPr lang="tr-TR" sz="2400" dirty="0">
               <a:latin typeface="Brush Script MT" panose="03060802040406070304" pitchFamily="66" charset="0"/>
@@ -6418,8 +6402,8 @@
         </p:nvSpPr>
         <p:spPr>
           <a:xfrm>
-            <a:off x="554918" y="1645106"/>
-            <a:ext cx="3024336" cy="523220"/>
+            <a:off x="683568" y="1645106"/>
+            <a:ext cx="3744416" cy="523220"/>
           </a:xfrm>
           <a:prstGeom prst="rect">
             <a:avLst/>
@@ -6461,7 +6445,7 @@
         <p:spPr>
           <a:xfrm>
             <a:off x="-20726" y="6211669"/>
-            <a:ext cx="4248472" cy="800219"/>
+            <a:ext cx="9144000" cy="800219"/>
           </a:xfrm>
           <a:prstGeom prst="rect">
             <a:avLst/>
@@ -7748,13 +7732,13 @@
           <p:nvPr>
             <p:extLst>
               <p:ext uri="{D42A27DB-BD31-4B8C-83A1-F6EECF244321}">
-                <p14:modId xmlns:p14="http://schemas.microsoft.com/office/powerpoint/2010/main" val="3005678602"/>
+                <p14:modId xmlns:p14="http://schemas.microsoft.com/office/powerpoint/2010/main" val="1607332946"/>
               </p:ext>
             </p:extLst>
           </p:nvPr>
         </p:nvGraphicFramePr>
         <p:xfrm>
-          <a:off x="5143500" y="296243"/>
+          <a:off x="5548436" y="348785"/>
           <a:ext cx="4000500" cy="4129091"/>
         </p:xfrm>
         <a:graphic>
@@ -9170,7 +9154,7 @@
         </p:nvSpPr>
         <p:spPr>
           <a:xfrm>
-            <a:off x="7143204" y="1821215"/>
+            <a:off x="6880984" y="1819651"/>
             <a:ext cx="2223864" cy="369332"/>
           </a:xfrm>
           <a:prstGeom prst="rect">
@@ -9205,7 +9189,7 @@
         </p:nvSpPr>
         <p:spPr>
           <a:xfrm>
-            <a:off x="7172672" y="1292954"/>
+            <a:off x="6880984" y="1288777"/>
             <a:ext cx="2223864" cy="369332"/>
           </a:xfrm>
           <a:prstGeom prst="rect">
@@ -18566,44 +18550,6 @@
           </a:p>
         </p:txBody>
       </p:sp>
-      <p:cxnSp>
-        <p:nvCxnSpPr>
-          <p:cNvPr id="8" name="10 Düz Bağlayıcı"/>
-          <p:cNvCxnSpPr/>
-          <p:nvPr/>
-        </p:nvCxnSpPr>
-        <p:spPr>
-          <a:xfrm flipH="1">
-            <a:off x="3786182" y="2340000"/>
-            <a:ext cx="615549" cy="2303446"/>
-          </a:xfrm>
-          <a:prstGeom prst="line">
-            <a:avLst/>
-          </a:prstGeom>
-          <a:ln w="12700">
-            <a:solidFill>
-              <a:schemeClr val="bg1">
-                <a:lumMod val="40000"/>
-                <a:lumOff val="60000"/>
-              </a:schemeClr>
-            </a:solidFill>
-          </a:ln>
-        </p:spPr>
-        <p:style>
-          <a:lnRef idx="1">
-            <a:schemeClr val="accent1"/>
-          </a:lnRef>
-          <a:fillRef idx="0">
-            <a:schemeClr val="accent1"/>
-          </a:fillRef>
-          <a:effectRef idx="0">
-            <a:schemeClr val="accent1"/>
-          </a:effectRef>
-          <a:fontRef idx="minor">
-            <a:schemeClr val="tx1"/>
-          </a:fontRef>
-        </p:style>
-      </p:cxnSp>
       <p:sp>
         <p:nvSpPr>
           <p:cNvPr id="7" name="TextBox 6">
@@ -19210,41 +19156,43 @@
           <a:bodyPr/>
           <a:lstStyle/>
           <a:p>
-            <a:pPr eaLnBrk="1" hangingPunct="1"/>
-            <a:endParaRPr lang="tr-TR" dirty="0">
-              <a:latin typeface="Arial Rounded MT Bold" pitchFamily="34" charset="0"/>
-            </a:endParaRPr>
-          </a:p>
-          <a:p>
             <a:pPr marL="0" indent="0" eaLnBrk="1" hangingPunct="1">
               <a:buNone/>
             </a:pPr>
-            <a:r>
-              <a:rPr lang="tr-TR" sz="2000" dirty="0">
+            <a:endParaRPr lang="tr-TR" b="1" dirty="0">
+              <a:latin typeface="Arial Rounded MT Bold" pitchFamily="34" charset="0"/>
+            </a:endParaRPr>
+          </a:p>
+          <a:p>
+            <a:pPr marL="0" indent="0" eaLnBrk="1" hangingPunct="1">
+              <a:buNone/>
+            </a:pPr>
+            <a:r>
+              <a:rPr lang="tr-TR" sz="2000" b="1" dirty="0">
                 <a:latin typeface="Arial Rounded MT Bold" pitchFamily="34" charset="0"/>
               </a:rPr>
               <a:t>     Dentally </a:t>
             </a:r>
             <a:r>
-              <a:rPr lang="en-US" sz="2000" dirty="0">
+              <a:rPr lang="en-US" sz="2000" b="1" dirty="0">
                 <a:latin typeface="Arial Rounded MT Bold" pitchFamily="34" charset="0"/>
               </a:rPr>
               <a:t>C</a:t>
             </a:r>
             <a:r>
-              <a:rPr lang="tr-TR" sz="2000" dirty="0">
+              <a:rPr lang="tr-TR" sz="2000" b="1" dirty="0">
                 <a:latin typeface="Arial Rounded MT Bold" pitchFamily="34" charset="0"/>
               </a:rPr>
               <a:t>lass II</a:t>
             </a:r>
             <a:r>
-              <a:rPr lang="en-US" sz="2000" dirty="0">
+              <a:rPr lang="en-US" sz="2000" b="1" dirty="0">
                 <a:latin typeface="Arial Rounded MT Bold" pitchFamily="34" charset="0"/>
               </a:rPr>
               <a:t> </a:t>
             </a:r>
             <a:r>
-              <a:rPr lang="tr-TR" sz="2000" dirty="0">
+              <a:rPr lang="tr-TR" sz="2000" b="1" dirty="0">
                 <a:latin typeface="Arial Rounded MT Bold" pitchFamily="34" charset="0"/>
               </a:rPr>
               <a:t>relationship</a:t>
@@ -19255,17 +19203,27 @@
               <a:buNone/>
             </a:pPr>
             <a:r>
-              <a:rPr lang="tr-TR" sz="2800" dirty="0">
+              <a:rPr lang="tr-TR" sz="2000" b="1" dirty="0">
                 <a:latin typeface="Arial Rounded MT Bold" pitchFamily="34" charset="0"/>
               </a:rPr>
-              <a:t>   </a:t>
-            </a:r>
-            <a:r>
-              <a:rPr lang="tr-TR" sz="2000" dirty="0">
-                <a:latin typeface="Arial Rounded MT Bold" pitchFamily="34" charset="0"/>
-              </a:rPr>
-              <a:t> Crowding</a:t>
-            </a:r>
+              <a:t>     Crowding</a:t>
+            </a:r>
+          </a:p>
+          <a:p>
+            <a:pPr marL="0" indent="0" eaLnBrk="1" hangingPunct="1">
+              <a:buNone/>
+            </a:pPr>
+            <a:endParaRPr lang="tr-TR" sz="2400" dirty="0">
+              <a:latin typeface="Arial Rounded MT Bold" pitchFamily="34" charset="0"/>
+            </a:endParaRPr>
+          </a:p>
+          <a:p>
+            <a:pPr marL="0" indent="0" eaLnBrk="1" hangingPunct="1">
+              <a:buNone/>
+            </a:pPr>
+            <a:endParaRPr lang="tr-TR" sz="2400" dirty="0">
+              <a:latin typeface="Arial Rounded MT Bold" pitchFamily="34" charset="0"/>
+            </a:endParaRPr>
           </a:p>
           <a:p>
             <a:pPr marL="0" indent="0" eaLnBrk="1" hangingPunct="1">
@@ -19277,6 +19235,23 @@
               </a:rPr>
               <a:t> </a:t>
             </a:r>
+            <a:endParaRPr lang="tr-TR" sz="2400" dirty="0">
+              <a:latin typeface="Arial Rounded MT Bold" pitchFamily="34" charset="0"/>
+            </a:endParaRPr>
+          </a:p>
+          <a:p>
+            <a:pPr marL="0" indent="0" eaLnBrk="1" hangingPunct="1">
+              <a:buNone/>
+            </a:pPr>
+            <a:endParaRPr lang="tr-TR" sz="2400" dirty="0">
+              <a:latin typeface="Arial Rounded MT Bold" pitchFamily="34" charset="0"/>
+            </a:endParaRPr>
+          </a:p>
+          <a:p>
+            <a:pPr eaLnBrk="1" hangingPunct="1"/>
+            <a:endParaRPr lang="en-US" sz="2400" dirty="0">
+              <a:latin typeface="Arial Rounded MT Bold" pitchFamily="34" charset="0"/>
+            </a:endParaRPr>
           </a:p>
           <a:p>
             <a:pPr marL="0" indent="0" eaLnBrk="1" hangingPunct="1">
@@ -19383,7 +19358,7 @@
         </p:nvSpPr>
         <p:spPr>
           <a:xfrm>
-            <a:off x="298992" y="1072880"/>
+            <a:off x="269100" y="1176206"/>
             <a:ext cx="8780784" cy="400110"/>
           </a:xfrm>
           <a:prstGeom prst="rect">
@@ -19420,7 +19395,7 @@
         </p:nvSpPr>
         <p:spPr>
           <a:xfrm>
-            <a:off x="329472" y="2485278"/>
+            <a:off x="296536" y="2345815"/>
             <a:ext cx="8858224" cy="400110"/>
           </a:xfrm>
           <a:prstGeom prst="rect">
@@ -19457,7 +19432,7 @@
         </p:nvSpPr>
         <p:spPr>
           <a:xfrm>
-            <a:off x="329472" y="3342602"/>
+            <a:off x="283884" y="3171388"/>
             <a:ext cx="8890008" cy="400110"/>
           </a:xfrm>
           <a:prstGeom prst="rect">
@@ -19494,7 +19469,7 @@
         </p:nvSpPr>
         <p:spPr>
           <a:xfrm>
-            <a:off x="329472" y="2915234"/>
+            <a:off x="283884" y="2767718"/>
             <a:ext cx="8890008" cy="400110"/>
           </a:xfrm>
           <a:prstGeom prst="rect">
@@ -19517,6 +19492,186 @@
           </a:p>
         </p:txBody>
       </p:sp>
+      <p:pic>
+        <p:nvPicPr>
+          <p:cNvPr id="9" name="Picture 8">
+            <a:extLst>
+              <a:ext uri="{FF2B5EF4-FFF2-40B4-BE49-F238E27FC236}">
+                <a16:creationId xmlns:a16="http://schemas.microsoft.com/office/drawing/2014/main" id="{76BAF33A-F052-42DE-B845-D74ACFBA4802}"/>
+              </a:ext>
+            </a:extLst>
+          </p:cNvPr>
+          <p:cNvPicPr>
+            <a:picLocks noChangeAspect="1"/>
+          </p:cNvPicPr>
+          <p:nvPr/>
+        </p:nvPicPr>
+        <p:blipFill>
+          <a:blip r:embed="rId2"/>
+          <a:stretch>
+            <a:fillRect/>
+          </a:stretch>
+        </p:blipFill>
+        <p:spPr>
+          <a:xfrm>
+            <a:off x="164325" y="1269361"/>
+            <a:ext cx="209550" cy="228600"/>
+          </a:xfrm>
+          <a:prstGeom prst="rect">
+            <a:avLst/>
+          </a:prstGeom>
+        </p:spPr>
+      </p:pic>
+      <p:pic>
+        <p:nvPicPr>
+          <p:cNvPr id="11" name="Picture 10">
+            <a:extLst>
+              <a:ext uri="{FF2B5EF4-FFF2-40B4-BE49-F238E27FC236}">
+                <a16:creationId xmlns:a16="http://schemas.microsoft.com/office/drawing/2014/main" id="{22767620-6821-4545-8D03-BB41A15E83A9}"/>
+              </a:ext>
+            </a:extLst>
+          </p:cNvPr>
+          <p:cNvPicPr>
+            <a:picLocks noChangeAspect="1"/>
+          </p:cNvPicPr>
+          <p:nvPr/>
+        </p:nvPicPr>
+        <p:blipFill>
+          <a:blip r:embed="rId2"/>
+          <a:stretch>
+            <a:fillRect/>
+          </a:stretch>
+        </p:blipFill>
+        <p:spPr>
+          <a:xfrm>
+            <a:off x="164325" y="1643665"/>
+            <a:ext cx="209550" cy="228600"/>
+          </a:xfrm>
+          <a:prstGeom prst="rect">
+            <a:avLst/>
+          </a:prstGeom>
+        </p:spPr>
+      </p:pic>
+      <p:pic>
+        <p:nvPicPr>
+          <p:cNvPr id="13" name="Picture 12">
+            <a:extLst>
+              <a:ext uri="{FF2B5EF4-FFF2-40B4-BE49-F238E27FC236}">
+                <a16:creationId xmlns:a16="http://schemas.microsoft.com/office/drawing/2014/main" id="{EA789B94-3FAB-441C-9E1F-CC0E8785156D}"/>
+              </a:ext>
+            </a:extLst>
+          </p:cNvPr>
+          <p:cNvPicPr>
+            <a:picLocks noChangeAspect="1"/>
+          </p:cNvPicPr>
+          <p:nvPr/>
+        </p:nvPicPr>
+        <p:blipFill>
+          <a:blip r:embed="rId2"/>
+          <a:stretch>
+            <a:fillRect/>
+          </a:stretch>
+        </p:blipFill>
+        <p:spPr>
+          <a:xfrm>
+            <a:off x="164325" y="2010839"/>
+            <a:ext cx="209550" cy="228600"/>
+          </a:xfrm>
+          <a:prstGeom prst="rect">
+            <a:avLst/>
+          </a:prstGeom>
+        </p:spPr>
+      </p:pic>
+      <p:pic>
+        <p:nvPicPr>
+          <p:cNvPr id="15" name="Picture 14">
+            <a:extLst>
+              <a:ext uri="{FF2B5EF4-FFF2-40B4-BE49-F238E27FC236}">
+                <a16:creationId xmlns:a16="http://schemas.microsoft.com/office/drawing/2014/main" id="{CA8565AF-84DD-473E-99EE-7A6487C1F04B}"/>
+              </a:ext>
+            </a:extLst>
+          </p:cNvPr>
+          <p:cNvPicPr>
+            <a:picLocks noChangeAspect="1"/>
+          </p:cNvPicPr>
+          <p:nvPr/>
+        </p:nvPicPr>
+        <p:blipFill>
+          <a:blip r:embed="rId2"/>
+          <a:stretch>
+            <a:fillRect/>
+          </a:stretch>
+        </p:blipFill>
+        <p:spPr>
+          <a:xfrm>
+            <a:off x="164325" y="2431570"/>
+            <a:ext cx="209550" cy="228600"/>
+          </a:xfrm>
+          <a:prstGeom prst="rect">
+            <a:avLst/>
+          </a:prstGeom>
+        </p:spPr>
+      </p:pic>
+      <p:pic>
+        <p:nvPicPr>
+          <p:cNvPr id="17" name="Picture 16">
+            <a:extLst>
+              <a:ext uri="{FF2B5EF4-FFF2-40B4-BE49-F238E27FC236}">
+                <a16:creationId xmlns:a16="http://schemas.microsoft.com/office/drawing/2014/main" id="{2E43240D-1299-4D41-BBEA-AFD5510660ED}"/>
+              </a:ext>
+            </a:extLst>
+          </p:cNvPr>
+          <p:cNvPicPr>
+            <a:picLocks noChangeAspect="1"/>
+          </p:cNvPicPr>
+          <p:nvPr/>
+        </p:nvPicPr>
+        <p:blipFill>
+          <a:blip r:embed="rId2"/>
+          <a:stretch>
+            <a:fillRect/>
+          </a:stretch>
+        </p:blipFill>
+        <p:spPr>
+          <a:xfrm>
+            <a:off x="164325" y="2868901"/>
+            <a:ext cx="209550" cy="228600"/>
+          </a:xfrm>
+          <a:prstGeom prst="rect">
+            <a:avLst/>
+          </a:prstGeom>
+        </p:spPr>
+      </p:pic>
+      <p:pic>
+        <p:nvPicPr>
+          <p:cNvPr id="20" name="Picture 19">
+            <a:extLst>
+              <a:ext uri="{FF2B5EF4-FFF2-40B4-BE49-F238E27FC236}">
+                <a16:creationId xmlns:a16="http://schemas.microsoft.com/office/drawing/2014/main" id="{C4C37EA3-66C7-4E74-A30E-1D712464ACD4}"/>
+              </a:ext>
+            </a:extLst>
+          </p:cNvPr>
+          <p:cNvPicPr>
+            <a:picLocks noChangeAspect="1"/>
+          </p:cNvPicPr>
+          <p:nvPr/>
+        </p:nvPicPr>
+        <p:blipFill>
+          <a:blip r:embed="rId2"/>
+          <a:stretch>
+            <a:fillRect/>
+          </a:stretch>
+        </p:blipFill>
+        <p:spPr>
+          <a:xfrm>
+            <a:off x="164325" y="3286916"/>
+            <a:ext cx="209550" cy="228600"/>
+          </a:xfrm>
+          <a:prstGeom prst="rect">
+            <a:avLst/>
+          </a:prstGeom>
+        </p:spPr>
+      </p:pic>
     </p:spTree>
     <p:extLst>
       <p:ext uri="{BB962C8B-B14F-4D97-AF65-F5344CB8AC3E}">
@@ -20846,39 +21001,6 @@
           </a:p>
         </p:txBody>
       </p:sp>
-      <p:cxnSp>
-        <p:nvCxnSpPr>
-          <p:cNvPr id="14" name="13 Düz Bağlayıcı"/>
-          <p:cNvCxnSpPr/>
-          <p:nvPr/>
-        </p:nvCxnSpPr>
-        <p:spPr>
-          <a:xfrm rot="16200000" flipH="1">
-            <a:off x="3762242" y="3431034"/>
-            <a:ext cx="1487137" cy="11637"/>
-          </a:xfrm>
-          <a:prstGeom prst="line">
-            <a:avLst/>
-          </a:prstGeom>
-          <a:ln w="19050" cmpd="sng">
-            <a:prstDash val="dash"/>
-          </a:ln>
-        </p:spPr>
-        <p:style>
-          <a:lnRef idx="1">
-            <a:schemeClr val="accent1"/>
-          </a:lnRef>
-          <a:fillRef idx="0">
-            <a:schemeClr val="accent1"/>
-          </a:fillRef>
-          <a:effectRef idx="0">
-            <a:schemeClr val="accent1"/>
-          </a:effectRef>
-          <a:fontRef idx="minor">
-            <a:schemeClr val="tx1"/>
-          </a:fontRef>
-        </p:style>
-      </p:cxnSp>
       <p:sp>
         <p:nvSpPr>
           <p:cNvPr id="15" name="TextBox 14">
@@ -20927,89 +21049,6 @@
   <p:clrMapOvr>
     <a:masterClrMapping/>
   </p:clrMapOvr>
-  <p:timing>
-    <p:tnLst>
-      <p:par>
-        <p:cTn id="1" dur="indefinite" restart="never" nodeType="tmRoot">
-          <p:childTnLst>
-            <p:seq concurrent="1" nextAc="seek">
-              <p:cTn id="2" dur="indefinite" nodeType="mainSeq">
-                <p:childTnLst>
-                  <p:par>
-                    <p:cTn id="3" fill="hold">
-                      <p:stCondLst>
-                        <p:cond delay="indefinite"/>
-                      </p:stCondLst>
-                      <p:childTnLst>
-                        <p:par>
-                          <p:cTn id="4" fill="hold">
-                            <p:stCondLst>
-                              <p:cond delay="0"/>
-                            </p:stCondLst>
-                            <p:childTnLst>
-                              <p:par>
-                                <p:cTn id="5" presetID="22" presetClass="entr" presetSubtype="1" fill="hold" nodeType="clickEffect">
-                                  <p:stCondLst>
-                                    <p:cond delay="0"/>
-                                  </p:stCondLst>
-                                  <p:childTnLst>
-                                    <p:set>
-                                      <p:cBhvr>
-                                        <p:cTn id="6" dur="1" fill="hold">
-                                          <p:stCondLst>
-                                            <p:cond delay="0"/>
-                                          </p:stCondLst>
-                                        </p:cTn>
-                                        <p:tgtEl>
-                                          <p:spTgt spid="14"/>
-                                        </p:tgtEl>
-                                        <p:attrNameLst>
-                                          <p:attrName>style.visibility</p:attrName>
-                                        </p:attrNameLst>
-                                      </p:cBhvr>
-                                      <p:to>
-                                        <p:strVal val="visible"/>
-                                      </p:to>
-                                    </p:set>
-                                    <p:animEffect transition="in" filter="wipe(up)">
-                                      <p:cBhvr>
-                                        <p:cTn id="7" dur="1000"/>
-                                        <p:tgtEl>
-                                          <p:spTgt spid="14"/>
-                                        </p:tgtEl>
-                                      </p:cBhvr>
-                                    </p:animEffect>
-                                  </p:childTnLst>
-                                </p:cTn>
-                              </p:par>
-                            </p:childTnLst>
-                          </p:cTn>
-                        </p:par>
-                      </p:childTnLst>
-                    </p:cTn>
-                  </p:par>
-                </p:childTnLst>
-              </p:cTn>
-              <p:prevCondLst>
-                <p:cond evt="onPrev" delay="0">
-                  <p:tgtEl>
-                    <p:sldTgt/>
-                  </p:tgtEl>
-                </p:cond>
-              </p:prevCondLst>
-              <p:nextCondLst>
-                <p:cond evt="onNext" delay="0">
-                  <p:tgtEl>
-                    <p:sldTgt/>
-                  </p:tgtEl>
-                </p:cond>
-              </p:nextCondLst>
-            </p:seq>
-          </p:childTnLst>
-        </p:cTn>
-      </p:par>
-    </p:tnLst>
-  </p:timing>
 </p:sld>
 </file>
 
@@ -22575,39 +22614,6 @@
           </a:p>
         </p:txBody>
       </p:sp>
-      <p:cxnSp>
-        <p:nvCxnSpPr>
-          <p:cNvPr id="5" name="4 Düz Bağlayıcı"/>
-          <p:cNvCxnSpPr/>
-          <p:nvPr/>
-        </p:nvCxnSpPr>
-        <p:spPr>
-          <a:xfrm>
-            <a:off x="4572000" y="206904"/>
-            <a:ext cx="0" cy="4365104"/>
-          </a:xfrm>
-          <a:prstGeom prst="line">
-            <a:avLst/>
-          </a:prstGeom>
-          <a:ln w="25400" cmpd="sng">
-            <a:prstDash val="dash"/>
-          </a:ln>
-        </p:spPr>
-        <p:style>
-          <a:lnRef idx="1">
-            <a:schemeClr val="accent1"/>
-          </a:lnRef>
-          <a:fillRef idx="0">
-            <a:schemeClr val="accent1"/>
-          </a:fillRef>
-          <a:effectRef idx="0">
-            <a:schemeClr val="accent1"/>
-          </a:effectRef>
-          <a:fontRef idx="minor">
-            <a:schemeClr val="tx1"/>
-          </a:fontRef>
-        </p:style>
-      </p:cxnSp>
       <p:sp>
         <p:nvSpPr>
           <p:cNvPr id="7" name="TextBox 6">
@@ -22622,7 +22628,7 @@
         </p:nvSpPr>
         <p:spPr>
           <a:xfrm>
-            <a:off x="1043608" y="4725144"/>
+            <a:off x="1331640" y="4725144"/>
             <a:ext cx="7200800" cy="523220"/>
           </a:xfrm>
           <a:prstGeom prst="rect">
@@ -22659,7 +22665,7 @@
         </p:nvSpPr>
         <p:spPr>
           <a:xfrm>
-            <a:off x="1043608" y="5084438"/>
+            <a:off x="1331640" y="5084438"/>
             <a:ext cx="7200800" cy="523220"/>
           </a:xfrm>
           <a:prstGeom prst="rect">
@@ -22766,89 +22772,6 @@
   <p:clrMapOvr>
     <a:masterClrMapping/>
   </p:clrMapOvr>
-  <p:timing>
-    <p:tnLst>
-      <p:par>
-        <p:cTn id="1" dur="indefinite" restart="never" nodeType="tmRoot">
-          <p:childTnLst>
-            <p:seq concurrent="1" nextAc="seek">
-              <p:cTn id="2" dur="indefinite" nodeType="mainSeq">
-                <p:childTnLst>
-                  <p:par>
-                    <p:cTn id="3" fill="hold">
-                      <p:stCondLst>
-                        <p:cond delay="indefinite"/>
-                      </p:stCondLst>
-                      <p:childTnLst>
-                        <p:par>
-                          <p:cTn id="4" fill="hold">
-                            <p:stCondLst>
-                              <p:cond delay="0"/>
-                            </p:stCondLst>
-                            <p:childTnLst>
-                              <p:par>
-                                <p:cTn id="5" presetID="22" presetClass="entr" presetSubtype="1" fill="hold" nodeType="clickEffect">
-                                  <p:stCondLst>
-                                    <p:cond delay="0"/>
-                                  </p:stCondLst>
-                                  <p:childTnLst>
-                                    <p:set>
-                                      <p:cBhvr>
-                                        <p:cTn id="6" dur="1" fill="hold">
-                                          <p:stCondLst>
-                                            <p:cond delay="0"/>
-                                          </p:stCondLst>
-                                        </p:cTn>
-                                        <p:tgtEl>
-                                          <p:spTgt spid="5"/>
-                                        </p:tgtEl>
-                                        <p:attrNameLst>
-                                          <p:attrName>style.visibility</p:attrName>
-                                        </p:attrNameLst>
-                                      </p:cBhvr>
-                                      <p:to>
-                                        <p:strVal val="visible"/>
-                                      </p:to>
-                                    </p:set>
-                                    <p:animEffect transition="in" filter="wipe(up)">
-                                      <p:cBhvr>
-                                        <p:cTn id="7" dur="1000"/>
-                                        <p:tgtEl>
-                                          <p:spTgt spid="5"/>
-                                        </p:tgtEl>
-                                      </p:cBhvr>
-                                    </p:animEffect>
-                                  </p:childTnLst>
-                                </p:cTn>
-                              </p:par>
-                            </p:childTnLst>
-                          </p:cTn>
-                        </p:par>
-                      </p:childTnLst>
-                    </p:cTn>
-                  </p:par>
-                </p:childTnLst>
-              </p:cTn>
-              <p:prevCondLst>
-                <p:cond evt="onPrev" delay="0">
-                  <p:tgtEl>
-                    <p:sldTgt/>
-                  </p:tgtEl>
-                </p:cond>
-              </p:prevCondLst>
-              <p:nextCondLst>
-                <p:cond evt="onNext" delay="0">
-                  <p:tgtEl>
-                    <p:sldTgt/>
-                  </p:tgtEl>
-                </p:cond>
-              </p:nextCondLst>
-            </p:seq>
-          </p:childTnLst>
-        </p:cTn>
-      </p:par>
-    </p:tnLst>
-  </p:timing>
 </p:sld>
 </file>
 
@@ -23094,114 +23017,6 @@
           </a:p>
         </p:txBody>
       </p:sp>
-      <p:cxnSp>
-        <p:nvCxnSpPr>
-          <p:cNvPr id="10" name="9 Düz Ok Bağlayıcısı"/>
-          <p:cNvCxnSpPr/>
-          <p:nvPr/>
-        </p:nvCxnSpPr>
-        <p:spPr>
-          <a:xfrm>
-            <a:off x="3357563" y="3571875"/>
-            <a:ext cx="357187" cy="1588"/>
-          </a:xfrm>
-          <a:prstGeom prst="straightConnector1">
-            <a:avLst/>
-          </a:prstGeom>
-          <a:ln w="22225">
-            <a:solidFill>
-              <a:srgbClr val="FF0000"/>
-            </a:solidFill>
-            <a:tailEnd type="arrow"/>
-          </a:ln>
-        </p:spPr>
-        <p:style>
-          <a:lnRef idx="1">
-            <a:schemeClr val="accent1"/>
-          </a:lnRef>
-          <a:fillRef idx="0">
-            <a:schemeClr val="accent1"/>
-          </a:fillRef>
-          <a:effectRef idx="0">
-            <a:schemeClr val="accent1"/>
-          </a:effectRef>
-          <a:fontRef idx="minor">
-            <a:schemeClr val="tx1"/>
-          </a:fontRef>
-        </p:style>
-      </p:cxnSp>
-      <p:cxnSp>
-        <p:nvCxnSpPr>
-          <p:cNvPr id="12" name="11 Düz Ok Bağlayıcısı"/>
-          <p:cNvCxnSpPr/>
-          <p:nvPr/>
-        </p:nvCxnSpPr>
-        <p:spPr>
-          <a:xfrm rot="10800000" flipV="1">
-            <a:off x="5857875" y="3286125"/>
-            <a:ext cx="428625" cy="214313"/>
-          </a:xfrm>
-          <a:prstGeom prst="straightConnector1">
-            <a:avLst/>
-          </a:prstGeom>
-          <a:ln w="19050">
-            <a:solidFill>
-              <a:srgbClr val="FF0000"/>
-            </a:solidFill>
-            <a:tailEnd type="arrow"/>
-          </a:ln>
-        </p:spPr>
-        <p:style>
-          <a:lnRef idx="1">
-            <a:schemeClr val="accent1"/>
-          </a:lnRef>
-          <a:fillRef idx="0">
-            <a:schemeClr val="accent1"/>
-          </a:fillRef>
-          <a:effectRef idx="0">
-            <a:schemeClr val="accent1"/>
-          </a:effectRef>
-          <a:fontRef idx="minor">
-            <a:schemeClr val="tx1"/>
-          </a:fontRef>
-        </p:style>
-      </p:cxnSp>
-      <p:cxnSp>
-        <p:nvCxnSpPr>
-          <p:cNvPr id="14" name="13 Düz Ok Bağlayıcısı"/>
-          <p:cNvCxnSpPr/>
-          <p:nvPr/>
-        </p:nvCxnSpPr>
-        <p:spPr>
-          <a:xfrm rot="5400000">
-            <a:off x="5429250" y="2714625"/>
-            <a:ext cx="357188" cy="71438"/>
-          </a:xfrm>
-          <a:prstGeom prst="straightConnector1">
-            <a:avLst/>
-          </a:prstGeom>
-          <a:ln w="19050">
-            <a:solidFill>
-              <a:srgbClr val="FF0000"/>
-            </a:solidFill>
-            <a:tailEnd type="arrow"/>
-          </a:ln>
-        </p:spPr>
-        <p:style>
-          <a:lnRef idx="1">
-            <a:schemeClr val="accent1"/>
-          </a:lnRef>
-          <a:fillRef idx="0">
-            <a:schemeClr val="accent1"/>
-          </a:fillRef>
-          <a:effectRef idx="0">
-            <a:schemeClr val="accent1"/>
-          </a:effectRef>
-          <a:fontRef idx="minor">
-            <a:schemeClr val="tx1"/>
-          </a:fontRef>
-        </p:style>
-      </p:cxnSp>
       <p:sp>
         <p:nvSpPr>
           <p:cNvPr id="12295" name="8 Metin kutusu"/>
@@ -23291,7 +23106,7 @@
         <p:spPr>
           <a:xfrm>
             <a:off x="0" y="-7502"/>
-            <a:ext cx="9144000" cy="4876365"/>
+            <a:ext cx="9144000" cy="4850013"/>
           </a:xfrm>
         </p:spPr>
         <p:txBody>

</xml_diff>

<commit_message>
Add doctor name field (Placeholder 300 = Dt. İsim Soyisim) + update sunum.pptx + rebuild dist (vDDvUXzk)
- Header: Hekim İsim Soyisim input, auto-capitalizes, stored as doctor_name
- Backend: doctor_name → 'Dt. X Y' format → Placeholder 300
- sunum.pptx: manual template update

Co-Authored-By: Claude Sonnet 4.6 <noreply@anthropic.com>
</commit_message>
<xml_diff>
--- a/sunum.pptx
+++ b/sunum.pptx
@@ -9154,7 +9154,7 @@
         </p:nvSpPr>
         <p:spPr>
           <a:xfrm>
-            <a:off x="6880984" y="1819651"/>
+            <a:off x="7596336" y="1819651"/>
             <a:ext cx="2223864" cy="369332"/>
           </a:xfrm>
           <a:prstGeom prst="rect">
@@ -9189,7 +9189,7 @@
         </p:nvSpPr>
         <p:spPr>
           <a:xfrm>
-            <a:off x="6880984" y="1288777"/>
+            <a:off x="7596336" y="1288777"/>
             <a:ext cx="2223864" cy="369332"/>
           </a:xfrm>
           <a:prstGeom prst="rect">
@@ -9224,7 +9224,7 @@
         </p:nvSpPr>
         <p:spPr>
           <a:xfrm>
-            <a:off x="7172672" y="2399598"/>
+            <a:off x="7596336" y="2399598"/>
             <a:ext cx="2376264" cy="369332"/>
           </a:xfrm>
           <a:prstGeom prst="rect">
@@ -9259,7 +9259,7 @@
         </p:nvSpPr>
         <p:spPr>
           <a:xfrm>
-            <a:off x="7149008" y="2955227"/>
+            <a:off x="7572672" y="2955227"/>
             <a:ext cx="2376264" cy="369332"/>
           </a:xfrm>
           <a:prstGeom prst="rect">
@@ -9294,7 +9294,7 @@
         </p:nvSpPr>
         <p:spPr>
           <a:xfrm>
-            <a:off x="7143204" y="3498806"/>
+            <a:off x="7566868" y="3498806"/>
             <a:ext cx="2376264" cy="369332"/>
           </a:xfrm>
           <a:prstGeom prst="rect">
@@ -9329,7 +9329,7 @@
         </p:nvSpPr>
         <p:spPr>
           <a:xfrm>
-            <a:off x="7143204" y="4042385"/>
+            <a:off x="7566868" y="4042385"/>
             <a:ext cx="2376264" cy="369332"/>
           </a:xfrm>
           <a:prstGeom prst="rect">
@@ -13677,7 +13677,7 @@
         </p:nvSpPr>
         <p:spPr>
           <a:xfrm>
-            <a:off x="7018332" y="2903562"/>
+            <a:off x="6982707" y="2903562"/>
             <a:ext cx="2376264" cy="369332"/>
           </a:xfrm>
           <a:prstGeom prst="rect">
@@ -13852,7 +13852,7 @@
         </p:nvSpPr>
         <p:spPr>
           <a:xfrm>
-            <a:off x="8295873" y="2891840"/>
+            <a:off x="8172400" y="2891840"/>
             <a:ext cx="1723549" cy="369332"/>
           </a:xfrm>
           <a:prstGeom prst="rect">
@@ -13867,10 +13867,9 @@
           <a:lstStyle/>
           <a:p>
             <a:r>
-              <a:rPr lang="tr-TR"/>
+              <a:rPr lang="tr-TR" dirty="0"/>
               <a:t>Placeholder 87</a:t>
             </a:r>
-            <a:endParaRPr lang="tr-TR" dirty="0"/>
           </a:p>
         </p:txBody>
       </p:sp>
@@ -18599,7 +18598,7 @@
         </p:nvSpPr>
         <p:spPr>
           <a:xfrm>
-            <a:off x="7175249" y="2434011"/>
+            <a:off x="7246499" y="2434011"/>
             <a:ext cx="2376264" cy="369332"/>
           </a:xfrm>
           <a:prstGeom prst="rect">
@@ -18634,7 +18633,7 @@
         </p:nvSpPr>
         <p:spPr>
           <a:xfrm>
-            <a:off x="7164288" y="1970668"/>
+            <a:off x="7235538" y="1970668"/>
             <a:ext cx="2376264" cy="369332"/>
           </a:xfrm>
           <a:prstGeom prst="rect">

</xml_diff>

<commit_message>
Add complaint options + free-text input + update sunum.pptx + rebuild dist (_sEbVRFN)
- Complaint field: select→datalist input (free text + predefined suggestions)
- Added: 'My lower jaw is on backward/forward position'
- sunum.pptx: manual template update

Co-Authored-By: Claude Sonnet 4.6 <noreply@anthropic.com>
</commit_message>
<xml_diff>
--- a/sunum.pptx
+++ b/sunum.pptx
@@ -7732,13 +7732,13 @@
           <p:nvPr>
             <p:extLst>
               <p:ext uri="{D42A27DB-BD31-4B8C-83A1-F6EECF244321}">
-                <p14:modId xmlns:p14="http://schemas.microsoft.com/office/powerpoint/2010/main" val="1607332946"/>
+                <p14:modId xmlns:p14="http://schemas.microsoft.com/office/powerpoint/2010/main" val="2008255780"/>
               </p:ext>
             </p:extLst>
           </p:nvPr>
         </p:nvGraphicFramePr>
         <p:xfrm>
-          <a:off x="5548436" y="348785"/>
+          <a:off x="4860032" y="348785"/>
           <a:ext cx="4000500" cy="4129091"/>
         </p:xfrm>
         <a:graphic>
@@ -9154,7 +9154,7 @@
         </p:nvSpPr>
         <p:spPr>
           <a:xfrm>
-            <a:off x="7596336" y="1819651"/>
+            <a:off x="6907932" y="1819651"/>
             <a:ext cx="2223864" cy="369332"/>
           </a:xfrm>
           <a:prstGeom prst="rect">
@@ -9189,7 +9189,7 @@
         </p:nvSpPr>
         <p:spPr>
           <a:xfrm>
-            <a:off x="7596336" y="1288777"/>
+            <a:off x="6907932" y="1288777"/>
             <a:ext cx="2223864" cy="369332"/>
           </a:xfrm>
           <a:prstGeom prst="rect">
@@ -9224,7 +9224,7 @@
         </p:nvSpPr>
         <p:spPr>
           <a:xfrm>
-            <a:off x="7596336" y="2399598"/>
+            <a:off x="6907932" y="2399598"/>
             <a:ext cx="2376264" cy="369332"/>
           </a:xfrm>
           <a:prstGeom prst="rect">
@@ -9259,7 +9259,7 @@
         </p:nvSpPr>
         <p:spPr>
           <a:xfrm>
-            <a:off x="7572672" y="2955227"/>
+            <a:off x="6884268" y="2955227"/>
             <a:ext cx="2376264" cy="369332"/>
           </a:xfrm>
           <a:prstGeom prst="rect">
@@ -9294,7 +9294,7 @@
         </p:nvSpPr>
         <p:spPr>
           <a:xfrm>
-            <a:off x="7566868" y="3498806"/>
+            <a:off x="6878464" y="3498806"/>
             <a:ext cx="2376264" cy="369332"/>
           </a:xfrm>
           <a:prstGeom prst="rect">
@@ -9329,7 +9329,7 @@
         </p:nvSpPr>
         <p:spPr>
           <a:xfrm>
-            <a:off x="7566868" y="4042385"/>
+            <a:off x="6878464" y="4042385"/>
             <a:ext cx="2376264" cy="369332"/>
           </a:xfrm>
           <a:prstGeom prst="rect">
@@ -13782,7 +13782,7 @@
         </p:nvSpPr>
         <p:spPr>
           <a:xfrm>
-            <a:off x="8206464" y="2144790"/>
+            <a:off x="8100392" y="2144790"/>
             <a:ext cx="1723549" cy="369332"/>
           </a:xfrm>
           <a:prstGeom prst="rect">
@@ -13817,7 +13817,7 @@
         </p:nvSpPr>
         <p:spPr>
           <a:xfrm>
-            <a:off x="8206464" y="1331478"/>
+            <a:off x="8100392" y="1331478"/>
             <a:ext cx="1723549" cy="369332"/>
           </a:xfrm>
           <a:prstGeom prst="rect">
@@ -13852,7 +13852,7 @@
         </p:nvSpPr>
         <p:spPr>
           <a:xfrm>
-            <a:off x="8172400" y="2891840"/>
+            <a:off x="8028384" y="2891840"/>
             <a:ext cx="1723549" cy="369332"/>
           </a:xfrm>
           <a:prstGeom prst="rect">

</xml_diff>